<commit_message>
male poprawki w svm
</commit_message>
<xml_diff>
--- a/Stroke.pptx
+++ b/Stroke.pptx
@@ -134,6 +134,11 @@
       </a:defRPr>
     </a:lvl9pPr>
   </p:defaultTextStyle>
+  <p:extLst>
+    <p:ext uri="{EFAFB233-063F-42B5-8137-9DF3F51BA10A}">
+      <p15:sldGuideLst xmlns:p15="http://schemas.microsoft.com/office/powerpoint/2012/main"/>
+    </p:ext>
+  </p:extLst>
 </p:presentation>
 </file>
 
@@ -306,7 +311,7 @@
           <a:p>
             <a:fld id="{E232D418-9E88-7943-90B6-0440B62E84A8}" type="datetimeFigureOut">
               <a:rPr lang="pl-PL" smtClean="0"/>
-              <a:t>11.05.2026</a:t>
+              <a:t>14.05.2026</a:t>
             </a:fld>
             <a:endParaRPr lang="pl-PL"/>
           </a:p>
@@ -636,7 +641,7 @@
           <a:p>
             <a:fld id="{E232D418-9E88-7943-90B6-0440B62E84A8}" type="datetimeFigureOut">
               <a:rPr lang="pl-PL" smtClean="0"/>
-              <a:t>11.05.2026</a:t>
+              <a:t>14.05.2026</a:t>
             </a:fld>
             <a:endParaRPr lang="pl-PL"/>
           </a:p>
@@ -816,7 +821,7 @@
           <a:p>
             <a:fld id="{E232D418-9E88-7943-90B6-0440B62E84A8}" type="datetimeFigureOut">
               <a:rPr lang="pl-PL" smtClean="0"/>
-              <a:t>11.05.2026</a:t>
+              <a:t>14.05.2026</a:t>
             </a:fld>
             <a:endParaRPr lang="pl-PL"/>
           </a:p>
@@ -986,7 +991,7 @@
           <a:p>
             <a:fld id="{E232D418-9E88-7943-90B6-0440B62E84A8}" type="datetimeFigureOut">
               <a:rPr lang="pl-PL" smtClean="0"/>
-              <a:t>11.05.2026</a:t>
+              <a:t>14.05.2026</a:t>
             </a:fld>
             <a:endParaRPr lang="pl-PL"/>
           </a:p>
@@ -1263,7 +1268,7 @@
           <a:p>
             <a:fld id="{E232D418-9E88-7943-90B6-0440B62E84A8}" type="datetimeFigureOut">
               <a:rPr lang="pl-PL" smtClean="0"/>
-              <a:t>11.05.2026</a:t>
+              <a:t>14.05.2026</a:t>
             </a:fld>
             <a:endParaRPr lang="pl-PL"/>
           </a:p>
@@ -1657,7 +1662,7 @@
           <a:p>
             <a:fld id="{E232D418-9E88-7943-90B6-0440B62E84A8}" type="datetimeFigureOut">
               <a:rPr lang="pl-PL" smtClean="0"/>
-              <a:t>11.05.2026</a:t>
+              <a:t>14.05.2026</a:t>
             </a:fld>
             <a:endParaRPr lang="pl-PL"/>
           </a:p>
@@ -2134,7 +2139,7 @@
           <a:p>
             <a:fld id="{E232D418-9E88-7943-90B6-0440B62E84A8}" type="datetimeFigureOut">
               <a:rPr lang="pl-PL" smtClean="0"/>
-              <a:t>11.05.2026</a:t>
+              <a:t>14.05.2026</a:t>
             </a:fld>
             <a:endParaRPr lang="pl-PL"/>
           </a:p>
@@ -2252,7 +2257,7 @@
           <a:p>
             <a:fld id="{E232D418-9E88-7943-90B6-0440B62E84A8}" type="datetimeFigureOut">
               <a:rPr lang="pl-PL" smtClean="0"/>
-              <a:t>11.05.2026</a:t>
+              <a:t>14.05.2026</a:t>
             </a:fld>
             <a:endParaRPr lang="pl-PL"/>
           </a:p>
@@ -2347,7 +2352,7 @@
           <a:p>
             <a:fld id="{E232D418-9E88-7943-90B6-0440B62E84A8}" type="datetimeFigureOut">
               <a:rPr lang="pl-PL" smtClean="0"/>
-              <a:t>11.05.2026</a:t>
+              <a:t>14.05.2026</a:t>
             </a:fld>
             <a:endParaRPr lang="pl-PL"/>
           </a:p>
@@ -2693,7 +2698,7 @@
           <a:p>
             <a:fld id="{E232D418-9E88-7943-90B6-0440B62E84A8}" type="datetimeFigureOut">
               <a:rPr lang="pl-PL" smtClean="0"/>
-              <a:t>11.05.2026</a:t>
+              <a:t>14.05.2026</a:t>
             </a:fld>
             <a:endParaRPr lang="pl-PL"/>
           </a:p>
@@ -3081,7 +3086,7 @@
           <a:p>
             <a:fld id="{E232D418-9E88-7943-90B6-0440B62E84A8}" type="datetimeFigureOut">
               <a:rPr lang="pl-PL" smtClean="0"/>
-              <a:t>11.05.2026</a:t>
+              <a:t>14.05.2026</a:t>
             </a:fld>
             <a:endParaRPr lang="pl-PL"/>
           </a:p>
@@ -3359,7 +3364,7 @@
           <a:p>
             <a:fld id="{E232D418-9E88-7943-90B6-0440B62E84A8}" type="datetimeFigureOut">
               <a:rPr lang="pl-PL" smtClean="0"/>
-              <a:t>11.05.2026</a:t>
+              <a:t>14.05.2026</a:t>
             </a:fld>
             <a:endParaRPr lang="pl-PL"/>
           </a:p>
@@ -6510,7 +6515,9 @@
           </a:xfrm>
         </p:spPr>
         <p:txBody>
-          <a:bodyPr/>
+          <a:bodyPr>
+            <a:normAutofit lnSpcReduction="10000"/>
+          </a:bodyPr>
           <a:lstStyle/>
           <a:p>
             <a:r>
@@ -6574,7 +6581,7 @@
           <a:p>
             <a:r>
               <a:rPr lang="pl-PL" dirty="0"/>
-              <a:t>Gamma – zasięg wpływu danych (dotyczy </a:t>
+              <a:t>Gamma – zasięg wpływu pojedynczego przykładu(dotyczy </a:t>
             </a:r>
             <a:r>
               <a:rPr lang="pl-PL" dirty="0" err="1"/>
@@ -6610,7 +6617,15 @@
             </a:r>
             <a:r>
               <a:rPr lang="pl-PL" dirty="0"/>
-              <a:t> – model zwraca uwagę na klasę z większą wagą.</a:t>
+              <a:t> – przy „</a:t>
+            </a:r>
+            <a:r>
+              <a:rPr lang="pl-PL" dirty="0" err="1"/>
+              <a:t>balanced</a:t>
+            </a:r>
+            <a:r>
+              <a:rPr lang="pl-PL" dirty="0"/>
+              <a:t>” model nadaje klasie mniejszościowej taką wagę, by liczyła się tak jak większościowa.</a:t>
             </a:r>
           </a:p>
         </p:txBody>
@@ -6861,15 +6876,15 @@
           <a:p>
             <a:r>
               <a:rPr lang="pl-PL" dirty="0"/>
-              <a:t>Zysk biznesowy – 0.25 mówi, że model zaryzykował, wskazał bardzo mało osób i zdobył prawdopodobnie </a:t>
+              <a:t>Zysk biznesowy – 0.25 mówi, że model zaryzykował, wskazał bardzo mało osób i prawdopodobnie </a:t>
             </a:r>
             <a:r>
               <a:rPr lang="pl-PL" b="1" dirty="0"/>
-              <a:t>1 punkt za trafienie (1 TP) oraz stracił 0.75 punktu za 3 fałszywe alarmy (3 FP)</a:t>
-            </a:r>
-            <a:r>
-              <a:rPr lang="pl-PL" dirty="0"/>
-              <a:t>.Przeoczył przy tym niemal wszystkich chorych pacjentów. Działa ledwie zauważalnie lepiej niż model, który milczy całkowicie (zysk 0.00).</a:t>
+              <a:t>5 punkt za trafienie (1 TP) oraz stracił 4,75 punktu za 19 fałszywych alarmów (3 FP)</a:t>
+            </a:r>
+            <a:r>
+              <a:rPr lang="pl-PL" dirty="0"/>
+              <a:t>.Przeoczył przy tym 90% pacjentów. Działa ledwie zauważalnie lepiej niż model, który milczy całkowicie (zysk 0.00).</a:t>
             </a:r>
           </a:p>
           <a:p>

</xml_diff>